<commit_message>
Slides : fix bloc YAML tronque (slide 7) + apercu monitoring plus lisible (slide 11)
</commit_message>
<xml_diff>
--- a/soutenance/soutenance.pptx
+++ b/soutenance/soutenance.pptx
@@ -1703,7 +1703,7 @@
         </p:nvPicPr>
         <p:blipFill>
           <a:blip r:embed="rId2"/>
-          <a:srcRect t="-68" b="-68"/>
+          <a:srcRect t="-3276" b="-3276"/>
           <a:stretch>
             <a:fillRect/>
           </a:stretch>
@@ -11572,7 +11572,7 @@
                 <a:latin typeface="JetBrains Mono"/>
                 <a:ea typeface="JetBrains Mono"/>
               </a:rPr>
-              <a:t>on:</a:t>
+              <a:t>on:  push: { branches: [main] }</a:t>
             </a:r>
             <a:endParaRPr lang="en-US" sz="1050" noProof="1"/>
           </a:p>
@@ -11581,6 +11581,9 @@
               <a:lnSpc>
                 <a:spcPct val="140000"/>
               </a:lnSpc>
+              <a:spcBef>
+                <a:spcPts val="600"/>
+              </a:spcBef>
             </a:pPr>
             <a:r>
               <a:rPr lang="en-US" sz="1050" noProof="1">
@@ -11590,7 +11593,7 @@
                 <a:latin typeface="JetBrains Mono"/>
                 <a:ea typeface="JetBrains Mono"/>
               </a:rPr>
-              <a:t>  push: { branches: [main] }</a:t>
+              <a:t>jobs:</a:t>
             </a:r>
             <a:endParaRPr lang="en-US" sz="1050" noProof="1"/>
           </a:p>
@@ -11599,9 +11602,6 @@
               <a:lnSpc>
                 <a:spcPct val="140000"/>
               </a:lnSpc>
-              <a:spcBef>
-                <a:spcPts val="800"/>
-              </a:spcBef>
             </a:pPr>
             <a:r>
               <a:rPr lang="en-US" sz="1050" noProof="1">
@@ -11611,53 +11611,45 @@
                 <a:latin typeface="JetBrains Mono"/>
                 <a:ea typeface="JetBrains Mono"/>
               </a:rPr>
-              <a:t>jobs:</a:t>
-            </a:r>
-            <a:endParaRPr lang="en-US" sz="1050" noProof="1"/>
-          </a:p>
-          <a:p>
-            <a:pPr>
-              <a:lnSpc>
-                <a:spcPct val="140000"/>
-              </a:lnSpc>
-            </a:pPr>
+              <a:t>  test:          </a:t>
+            </a:r>
             <a:r>
               <a:rPr lang="en-US" sz="1050" noProof="1">
                 <a:solidFill>
-                  <a:srgbClr val="E8EDF2"/>
+                  <a:srgbClr val="8FA9BF"/>
                 </a:solidFill>
                 <a:latin typeface="JetBrains Mono"/>
                 <a:ea typeface="JetBrains Mono"/>
               </a:rPr>
-              <a:t>  test:         </a:t>
-            </a:r>
+              <a:t># pytest (21 tests)</a:t>
+            </a:r>
+            <a:endParaRPr lang="en-US" sz="1050" noProof="1"/>
+          </a:p>
+          <a:p>
+            <a:pPr>
+              <a:lnSpc>
+                <a:spcPct val="140000"/>
+              </a:lnSpc>
+            </a:pPr>
             <a:r>
               <a:rPr lang="en-US" sz="1050" noProof="1">
                 <a:solidFill>
-                  <a:srgbClr val="8FA9BF"/>
+                  <a:srgbClr val="E8EDF2"/>
                 </a:solidFill>
                 <a:latin typeface="JetBrains Mono"/>
                 <a:ea typeface="JetBrains Mono"/>
               </a:rPr>
-              <a:t># pytest</a:t>
-            </a:r>
-            <a:endParaRPr lang="en-US" sz="1050" noProof="1"/>
-          </a:p>
-          <a:p>
-            <a:pPr>
-              <a:lnSpc>
-                <a:spcPct val="140000"/>
-              </a:lnSpc>
-            </a:pPr>
+              <a:t>  docker-build:  </a:t>
+            </a:r>
             <a:r>
               <a:rPr lang="en-US" sz="1050" noProof="1">
                 <a:solidFill>
-                  <a:srgbClr val="E8EDF2"/>
+                  <a:srgbClr val="8FA9BF"/>
                 </a:solidFill>
                 <a:latin typeface="JetBrains Mono"/>
                 <a:ea typeface="JetBrains Mono"/>
               </a:rPr>
-              <a:t>    steps: [checkout, setup-python 3.12,</a:t>
+              <a:t># needs: test</a:t>
             </a:r>
             <a:endParaRPr lang="en-US" sz="1050" noProof="1"/>
           </a:p>
@@ -11675,35 +11667,35 @@
                 <a:latin typeface="JetBrains Mono"/>
                 <a:ea typeface="JetBrains Mono"/>
               </a:rPr>
-              <a:t>            pip install, pytest tests/]</a:t>
-            </a:r>
-            <a:endParaRPr lang="en-US" sz="1050" noProof="1"/>
-          </a:p>
-          <a:p>
-            <a:pPr>
-              <a:lnSpc>
-                <a:spcPct val="140000"/>
-              </a:lnSpc>
-            </a:pPr>
+              <a:t>  deploy:        </a:t>
+            </a:r>
             <a:r>
               <a:rPr lang="en-US" sz="1050" noProof="1">
                 <a:solidFill>
-                  <a:srgbClr val="E8EDF2"/>
+                  <a:srgbClr val="8FA9BF"/>
                 </a:solidFill>
                 <a:latin typeface="JetBrains Mono"/>
                 <a:ea typeface="JetBrains Mono"/>
               </a:rPr>
-              <a:t>  docker-build: </a:t>
-            </a:r>
+              <a:t># needs: docker-build</a:t>
+            </a:r>
+            <a:endParaRPr lang="en-US" sz="1050" noProof="1"/>
+          </a:p>
+          <a:p>
+            <a:pPr>
+              <a:lnSpc>
+                <a:spcPct val="140000"/>
+              </a:lnSpc>
+            </a:pPr>
             <a:r>
               <a:rPr lang="en-US" sz="1050" noProof="1">
                 <a:solidFill>
-                  <a:srgbClr val="8FA9BF"/>
+                  <a:srgbClr val="E8EDF2"/>
                 </a:solidFill>
                 <a:latin typeface="JetBrains Mono"/>
                 <a:ea typeface="JetBrains Mono"/>
               </a:rPr>
-              <a:t># needs: test</a:t>
+              <a:t>    if: github.ref == 'refs/heads/main'</a:t>
             </a:r>
             <a:endParaRPr lang="en-US" sz="1050" noProof="1"/>
           </a:p>
@@ -11721,71 +11713,7 @@
                 <a:latin typeface="JetBrains Mono"/>
                 <a:ea typeface="JetBrains Mono"/>
               </a:rPr>
-              <a:t>  deploy:       </a:t>
-            </a:r>
-            <a:r>
-              <a:rPr lang="en-US" sz="1050" noProof="1">
-                <a:solidFill>
-                  <a:srgbClr val="8FA9BF"/>
-                </a:solidFill>
-                <a:latin typeface="JetBrains Mono"/>
-                <a:ea typeface="JetBrains Mono"/>
-              </a:rPr>
-              <a:t># needs: docker-build</a:t>
-            </a:r>
-            <a:endParaRPr lang="en-US" sz="1050" noProof="1"/>
-          </a:p>
-          <a:p>
-            <a:pPr>
-              <a:lnSpc>
-                <a:spcPct val="140000"/>
-              </a:lnSpc>
-            </a:pPr>
-            <a:r>
-              <a:rPr lang="en-US" sz="1050" noProof="1">
-                <a:solidFill>
-                  <a:srgbClr val="E8EDF2"/>
-                </a:solidFill>
-                <a:latin typeface="JetBrains Mono"/>
-                <a:ea typeface="JetBrains Mono"/>
-              </a:rPr>
-              <a:t>    if: github.ref == 'refs/heads/main'</a:t>
-            </a:r>
-            <a:endParaRPr lang="en-US" sz="1050" noProof="1"/>
-          </a:p>
-          <a:p>
-            <a:pPr>
-              <a:lnSpc>
-                <a:spcPct val="140000"/>
-              </a:lnSpc>
-            </a:pPr>
-            <a:r>
-              <a:rPr lang="en-US" sz="1050" noProof="1">
-                <a:solidFill>
-                  <a:srgbClr val="E8EDF2"/>
-                </a:solidFill>
-                <a:latin typeface="JetBrains Mono"/>
-                <a:ea typeface="JetBrains Mono"/>
-              </a:rPr>
-              <a:t>    steps: [docker run, curl /health,</a:t>
-            </a:r>
-            <a:endParaRPr lang="en-US" sz="1050" noProof="1"/>
-          </a:p>
-          <a:p>
-            <a:pPr>
-              <a:lnSpc>
-                <a:spcPct val="140000"/>
-              </a:lnSpc>
-            </a:pPr>
-            <a:r>
-              <a:rPr lang="en-US" sz="1050" noProof="1">
-                <a:solidFill>
-                  <a:srgbClr val="E8EDF2"/>
-                </a:solidFill>
-                <a:latin typeface="JetBrains Mono"/>
-                <a:ea typeface="JetBrains Mono"/>
-              </a:rPr>
-              <a:t>            curl /predict]</a:t>
+              <a:t>    steps: [docker run, curl /health, /predict]</a:t>
             </a:r>
             <a:endParaRPr lang="en-US" sz="1050" noProof="1"/>
           </a:p>

</xml_diff>